<commit_message>
Connect P0-01 original PDF to real PC production smoke
</commit_message>
<xml_diff>
--- a/docs/product/ppt-benchmark-materials/PPT-P0-01/p0-01-reference.pptx
+++ b/docs/product/ppt-benchmark-materials/PPT-P0-01/p0-01-reference.pptx
@@ -930,7 +930,7 @@
               <a:rPr lang="en-US" dirty="0"/>
               <a:t>访谈设计与样本流失
 待科研专业审阅；所有主张仅限冻结原文，不代表真实 PowerPoint 宿主验收。
-[sample] Deardorff 2020，PLOS ONE e0230697 · PDF 第 5 页
+[sample] doi:10.1371/journal.pone.0230697 · 第 5 页
 培训前 14 人、三个月后 12 人
 Attribution supplied by the input; source accuracy and license rights have not been independently verified.</a:t>
             </a:r>
@@ -1112,7 +1112,7 @@
               <a:rPr lang="en-US" dirty="0"/>
               <a:t>清单均分：不可夸大变化
 待科研专业审阅；所有主张仅限冻结原文，不代表真实 PowerPoint 宿主验收。
-[score] Deardorff 2020，PLOS ONE e0230697 · PDF 第 5 页
+[score] doi:10.1371/journal.pone.0230697 · 第 5 页
 均分 1.6/6 到 2.2/6；p=0.318
 Attribution supplied by the input; source accuracy and license rights have not been independently verified.</a:t>
             </a:r>
@@ -1204,7 +1204,7 @@
               <a:rPr lang="en-US" dirty="0"/>
               <a:t>Table 1：开源工具使用
 待科研专业审阅；所有主张仅限冻结原文，不代表真实 PowerPoint 宿主验收。
-[open-source] Deardorff 2020，PLOS ONE e0230697 · PDF 第 5 页 Table 1
+[open-source] doi:10.1371/journal.pone.0230697 · 第 5 页
 开源软件使用 7/14 到 10/12
 Attribution supplied by the input; source accuracy and license rights have not been independently verified.</a:t>
             </a:r>
@@ -1296,7 +1296,7 @@
               <a:rPr lang="en-US" dirty="0"/>
               <a:t>定性观察与研究局限
 待科研专业审阅；所有主张仅限冻结原文，不代表真实 PowerPoint 宿主验收。
-[limitations] Deardorff 2020，PLOS ONE e0230697 · PDF 第 9 页
+[limitations] doi:10.1371/journal.pone.0230697 · 第 9 页
 小样本、选择/应答、单人编码和功效限制
 Attribution supplied by the input; source accuracy and license rights have not been independently verified.</a:t>
             </a:r>
@@ -2209,7 +2209,7 @@
                 <a:ea typeface="Noto Sans CJK SC" pitchFamily="34" charset="-122"/>
                 <a:cs typeface="Noto Sans CJK SC" pitchFamily="34" charset="-120"/>
               </a:rPr>
-              <a:t>[sample] Deardorff 2020，PLOS ONE e0230697 · PDF 第 5 页</a:t>
+              <a:t>[sample] doi:10.1371/journal.pone.0230697 · 第 5 页</a:t>
             </a:r>
             <a:endParaRPr lang="en-US" sz="800" dirty="0"/>
           </a:p>
@@ -2546,7 +2546,7 @@
                 <a:ea typeface="Noto Sans CJK SC" pitchFamily="34" charset="-122"/>
                 <a:cs typeface="Noto Sans CJK SC" pitchFamily="34" charset="-120"/>
               </a:rPr>
-              <a:t>[score] Deardorff 2020，PLOS ONE e0230697 · PDF 第 5 页</a:t>
+              <a:t>[score] doi:10.1371/journal.pone.0230697 · 第 5 页</a:t>
             </a:r>
             <a:endParaRPr lang="en-US" sz="800" dirty="0"/>
           </a:p>
@@ -2750,7 +2750,7 @@
                 <a:ea typeface="Noto Sans CJK SC" pitchFamily="34" charset="-122"/>
                 <a:cs typeface="Noto Sans CJK SC" pitchFamily="34" charset="-120"/>
               </a:rPr>
-              <a:t>[open-source] Deardorff 2020，PLOS ONE e0230697 · PDF 第 5 页 Table 1</a:t>
+              <a:t>[open-source] doi:10.1371/journal.pone.0230697 · 第 5 页</a:t>
             </a:r>
             <a:endParaRPr lang="en-US" sz="800" dirty="0"/>
           </a:p>
@@ -2938,7 +2938,7 @@
                 <a:ea typeface="Noto Sans CJK SC" pitchFamily="34" charset="-122"/>
                 <a:cs typeface="Noto Sans CJK SC" pitchFamily="34" charset="-120"/>
               </a:rPr>
-              <a:t>[limitations] Deardorff 2020，PLOS ONE e0230697 · PDF 第 9 页</a:t>
+              <a:t>[limitations] doi:10.1371/journal.pone.0230697 · 第 9 页</a:t>
             </a:r>
             <a:endParaRPr lang="en-US" sz="800" dirty="0"/>
           </a:p>

</xml_diff>

<commit_message>
Build P0-03 calculated chart deck and distinguish chart series
</commit_message>
<xml_diff>
--- a/docs/product/ppt-benchmark-materials/PPT-P0-01/p0-01-reference.pptx
+++ b/docs/product/ppt-benchmark-materials/PPT-P0-01/p0-01-reference.pptx
@@ -148,7 +148,7 @@
           </c:spPr>
           <c:invertIfNegative val="0"/>
           <c:dLbls>
-            <c:numFmt formatCode="#,##0" sourceLinked="0"/>
+            <c:numFmt formatCode="#,##0.########" sourceLinked="0"/>
             <c:txPr>
               <a:bodyPr/>
               <a:lstStyle/>
@@ -204,7 +204,7 @@
           </c:val>
         </c:ser>
         <c:dLbls>
-          <c:numFmt formatCode="#,##0" sourceLinked="0"/>
+          <c:numFmt formatCode="#,##0.########" sourceLinked="0"/>
           <c:txPr>
             <a:bodyPr/>
             <a:lstStyle/>

</xml_diff>